<commit_message>
Apply requested edits: slide 7 heading/layout, WILAN, typos, figures
- Slide 7 retitled 'Project Cost and Funding Plan' (eyebrow THE PLAN)
- Rearranged slide 7 tables to remove overlap and align cleanly
- 'William National Head Girl Price' -> 'Winning the National Head Girl Prize'
- LILAN -> WILAN on conclusion slide
- Slide 9 typos fixed (employment, production, supplied, not, Students, pollution)
- Slide 10 'wasted every year' figure corrected to 1.56m
- Removed typo-named duplicate and PowerPoint lock file

Co-authored-by: arena-agent <297053741+arena-agent@users.noreply.github.com>
</commit_message>
<xml_diff>
--- a/deliverables/Bioclean_Smart_Biogas_Presentation.pptx
+++ b/deliverables/Bioclean_Smart_Biogas_Presentation.pptx
@@ -4485,7 +4485,7 @@
                 </a:solidFill>
                 <a:latin typeface="Calibri" panose="020F0502020204030204"/>
               </a:rPr>
-              <a:t>Invest ₦1,000,000 in me today. In return, LILAN gets a national model of student-led climate action that saves money, saves the planet and saves lives.</a:t>
+              <a:t>Invest ₦1,000,000 in me today. In return, WILAN gets a national model of student-led climate action that saves money, saves the planet and saves lives.</a:t>
             </a:r>
             <a:endParaRPr sz="1400" b="1" i="0">
               <a:solidFill>
@@ -9655,7 +9655,7 @@
                 </a:solidFill>
                 <a:latin typeface="Calibri" panose="020F0502020204030204"/>
               </a:rPr>
-              <a:t>THE PEOPLE</a:t>
+              <a:t>THE PLAN</a:t>
             </a:r>
             <a:endParaRPr sz="1250" b="1" i="0">
               <a:solidFill>
@@ -9706,7 +9706,7 @@
                 </a:solidFill>
                 <a:latin typeface="Calibri" panose="020F0502020204030204"/>
               </a:rPr>
-              <a:t>Key Metrics &amp; Sustainability and Leadership Plan</a:t>
+              <a:t>Project Cost and Funding Plan</a:t>
             </a:r>
             <a:endParaRPr sz="2600" b="1" i="0">
               <a:solidFill>
@@ -9865,57 +9865,6 @@
             <a:endParaRPr sz="900" b="1" i="0">
               <a:solidFill>
                 <a:srgbClr val="5A6B66"/>
-              </a:solidFill>
-              <a:latin typeface="Calibri" panose="020F0502020204030204"/>
-            </a:endParaRPr>
-          </a:p>
-        </p:txBody>
-      </p:sp>
-      <p:sp>
-        <p:nvSpPr>
-          <p:cNvPr id="9" name="TextBox 8"/>
-          <p:cNvSpPr txBox="1"/>
-          <p:nvPr/>
-        </p:nvSpPr>
-        <p:spPr>
-          <a:xfrm>
-            <a:off x="868680" y="1255268"/>
-            <a:ext cx="5029200" cy="365760"/>
-          </a:xfrm>
-          <a:prstGeom prst="rect">
-            <a:avLst/>
-          </a:prstGeom>
-          <a:noFill/>
-        </p:spPr>
-        <p:txBody>
-          <a:bodyPr wrap="square" lIns="0" tIns="0" rIns="0" bIns="0" anchor="t">
-            <a:spAutoFit/>
-          </a:bodyPr>
-          <a:lstStyle/>
-          <a:p>
-            <a:pPr algn="l">
-              <a:lnSpc>
-                <a:spcPct val="100000"/>
-              </a:lnSpc>
-              <a:spcBef>
-                <a:spcPts val="0"/>
-              </a:spcBef>
-              <a:spcAft>
-                <a:spcPts val="0"/>
-              </a:spcAft>
-            </a:pPr>
-            <a:r>
-              <a:rPr sz="1500" b="1" i="0">
-                <a:solidFill>
-                  <a:srgbClr val="1B7A4E"/>
-                </a:solidFill>
-                <a:latin typeface="Calibri" panose="020F0502020204030204"/>
-              </a:rPr>
-              <a:t>Key metrics</a:t>
-            </a:r>
-            <a:endParaRPr sz="1500" b="1" i="0">
-              <a:solidFill>
-                <a:srgbClr val="1B7A4E"/>
               </a:solidFill>
               <a:latin typeface="Calibri" panose="020F0502020204030204"/>
             </a:endParaRPr>
@@ -9935,8 +9884,8 @@
           </p:nvPr>
         </p:nvGraphicFramePr>
         <p:xfrm>
-          <a:off x="868680" y="840740"/>
-          <a:ext cx="10583545" cy="3048000"/>
+          <a:off x="868680" y="1627632"/>
+          <a:ext cx="10583545" cy="2377440"/>
         </p:xfrm>
         <a:graphic>
           <a:graphicData uri="http://schemas.openxmlformats.org/drawingml/2006/table">
@@ -9949,7 +9898,7 @@
                 <a:gridCol w="3135630"/>
                 <a:gridCol w="2429510"/>
               </a:tblGrid>
-              <a:tr h="424815">
+              <a:tr h="411480">
                 <a:tc>
                   <a:txBody>
                     <a:bodyPr wrap="square"/>
@@ -10038,7 +9987,7 @@
                   </a:tcPr>
                 </a:tc>
               </a:tr>
-              <a:tr h="655320">
+              <a:tr h="493776">
                 <a:tc>
                   <a:txBody>
                     <a:bodyPr wrap="square"/>
@@ -10133,7 +10082,7 @@
                   </a:tcPr>
                 </a:tc>
               </a:tr>
-              <a:tr h="655955">
+              <a:tr h="493776">
                 <a:tc>
                   <a:txBody>
                     <a:bodyPr wrap="square"/>
@@ -10219,7 +10168,7 @@
                   </a:tcPr>
                 </a:tc>
               </a:tr>
-              <a:tr h="655955">
+              <a:tr h="493776">
                 <a:tc>
                   <a:txBody>
                     <a:bodyPr wrap="square"/>
@@ -10305,7 +10254,7 @@
                   </a:tcPr>
                 </a:tc>
               </a:tr>
-              <a:tr h="655955">
+              <a:tr h="484632">
                 <a:tc>
                   <a:txBody>
                     <a:bodyPr/>
@@ -10414,8 +10363,8 @@
           </p:nvPr>
         </p:nvGraphicFramePr>
         <p:xfrm>
-          <a:off x="754380" y="4218940"/>
-          <a:ext cx="10583545" cy="2392045"/>
+          <a:off x="868680" y="4407408"/>
+          <a:ext cx="10583545" cy="1874520"/>
         </p:xfrm>
         <a:graphic>
           <a:graphicData uri="http://schemas.openxmlformats.org/drawingml/2006/table">
@@ -10427,7 +10376,7 @@
                 <a:gridCol w="5018405"/>
                 <a:gridCol w="5362575"/>
               </a:tblGrid>
-              <a:tr h="424815">
+              <a:tr h="411480">
                 <a:tc>
                   <a:txBody>
                     <a:bodyPr wrap="square"/>
@@ -10487,7 +10436,7 @@
                   </a:tcPr>
                 </a:tc>
               </a:tr>
-              <a:tr h="655320">
+              <a:tr h="484632">
                 <a:tc>
                   <a:txBody>
                     <a:bodyPr wrap="square"/>
@@ -10500,7 +10449,7 @@
                           </a:solidFill>
                           <a:latin typeface="Calibri" panose="020F0502020204030204"/>
                         </a:rPr>
-                        <a:t>William National Head Girl Price</a:t>
+                        <a:t>Winning the National Head Girl Prize</a:t>
                       </a:r>
                       <a:endParaRPr lang="en-US" sz="1800" b="1" i="0">
                         <a:solidFill>
@@ -10545,7 +10494,7 @@
                   </a:tcPr>
                 </a:tc>
               </a:tr>
-              <a:tr h="655955">
+              <a:tr h="484632">
                 <a:tc>
                   <a:txBody>
                     <a:bodyPr wrap="square"/>
@@ -10603,7 +10552,7 @@
                   </a:tcPr>
                 </a:tc>
               </a:tr>
-              <a:tr h="655955">
+              <a:tr h="493776">
                 <a:tc>
                   <a:txBody>
                     <a:bodyPr wrap="square"/>
@@ -10698,7 +10647,7 @@
         </p:nvSpPr>
         <p:spPr>
           <a:xfrm>
-            <a:off x="2567305" y="3915410"/>
+            <a:off x="868680" y="4133087"/>
             <a:ext cx="6530975" cy="368300"/>
           </a:xfrm>
           <a:prstGeom prst="rect">
@@ -13206,7 +13155,7 @@
                 </a:solidFill>
                 <a:latin typeface="Calibri" panose="020F0502020204030204"/>
               </a:rPr>
-              <a:t>The utilization of biogas would minimize the use of petrol and cooking gas which may not be affordable for most families, Moreover my BSBS would create emplyment opportunities for skilled residents who are willing to work</a:t>
+              <a:t>The utilization of biogas would minimize the use of petrol and cooking gas which may not be affordable for most families, Moreover my BSBS would create employment opportunities for skilled residents who are willing to work</a:t>
             </a:r>
             <a:endParaRPr sz="1080" b="0" i="0">
               <a:solidFill>
@@ -13316,7 +13265,7 @@
                 </a:solidFill>
                 <a:latin typeface="Calibri" panose="020F0502020204030204"/>
               </a:rPr>
-              <a:t> left behind after the prodcution </a:t>
+              <a:t> left behind after the production </a:t>
             </a:r>
             <a:r>
               <a:rPr sz="1080" b="0" i="0">
@@ -13343,7 +13292,7 @@
                 </a:solidFill>
                 <a:latin typeface="Calibri" panose="020F0502020204030204"/>
               </a:rPr>
-              <a:t> supply</a:t>
+              <a:t> supplied</a:t>
             </a:r>
             <a:r>
               <a:rPr lang="en-US" sz="1080" b="0" i="0">
@@ -13352,7 +13301,7 @@
                 </a:solidFill>
                 <a:latin typeface="Calibri" panose="020F0502020204030204"/>
               </a:rPr>
-              <a:t>ed</a:t>
+              <a:t/>
             </a:r>
             <a:r>
               <a:rPr sz="1080" b="0" i="0">
@@ -13510,7 +13459,7 @@
                 </a:solidFill>
                 <a:latin typeface="Calibri" panose="020F0502020204030204"/>
               </a:rPr>
-              <a:t>Student</a:t>
+              <a:t>Students</a:t>
             </a:r>
             <a:r>
               <a:rPr lang="en-US" sz="1080" b="0" i="0">
@@ -13519,7 +13468,7 @@
                 </a:solidFill>
                 <a:latin typeface="Calibri" panose="020F0502020204030204"/>
               </a:rPr>
-              <a:t> will nto have to feel </a:t>
+              <a:t> will not have to feel </a:t>
             </a:r>
             <a:r>
               <a:rPr sz="1080" b="0" i="0">
@@ -13609,7 +13558,7 @@
                 </a:solidFill>
                 <a:latin typeface="Calibri" panose="020F0502020204030204"/>
               </a:rPr>
-              <a:t>, there will be a decrease in air pollutions</a:t>
+              <a:t>, there will be a decrease in air pollution</a:t>
             </a:r>
             <a:endParaRPr lang="en-US" sz="1080" b="0" i="0">
               <a:solidFill>

</xml_diff>